<commit_message>
Fill team name Hawkeye into the SIH deck; fix S1 overflow + badge wrap
- Team Name (Registered on portal)- Hawkeye on slide 1; 'Hawkeye' badge
  on slides 2-6 (Team ID left blank until the portal assigns one)
- S1 details block: template used double line-spacing + justify — the
  filled block (PS title wraps to 3 lines) pushed the last two lines
  past the slide bottom; now 1.1 spacing, left-aligned, all lines visible
- Badge is an ellipse: PowerPoint lays text out in the inscribed rect
  (~w/√2), so 'Hawkeye' wrapped mid-word at any inherited size — widened
  the shape to 2.0in and set 18pt bold Arial explicitly

QA: PowerPoint re-export, all 6 slides judged pass.
</commit_message>
<xml_diff>
--- a/deck/UnifyMat-SIH2026-Idea.pptx
+++ b/deck/UnifyMat-SIH2026-Idea.pptx
@@ -5649,12 +5649,17 @@
           </a:bodyPr>
           <a:lstStyle/>
           <a:p>
+            <a:pPr algn="l">
+              <a:lnSpc>
+                <a:spcPct val="110000"/>
+              </a:lnSpc>
+            </a:pPr>
             <a:endParaRPr lang="en-US" dirty="0"/>
           </a:p>
           <a:p>
-            <a:pPr marL="285750" indent="-285750" algn="just">
+            <a:pPr marL="285750" indent="-285750" algn="l">
               <a:lnSpc>
-                <a:spcPct val="200000"/>
+                <a:spcPct val="110000"/>
               </a:lnSpc>
               <a:buFont typeface="Arial" panose="020B0604020202020204" pitchFamily="34" charset="0"/>
               <a:buChar char="•"/>
@@ -5668,9 +5673,9 @@
             </a:r>
           </a:p>
           <a:p>
-            <a:pPr marL="285750" indent="-285750" algn="just">
+            <a:pPr marL="285750" indent="-285750" algn="l">
               <a:lnSpc>
-                <a:spcPct val="200000"/>
+                <a:spcPct val="110000"/>
               </a:lnSpc>
               <a:buFont typeface="Arial" panose="020B0604020202020204" pitchFamily="34" charset="0"/>
               <a:buChar char="•"/>
@@ -5684,9 +5689,9 @@
             </a:r>
           </a:p>
           <a:p>
-            <a:pPr marL="285750" indent="-285750" algn="just">
+            <a:pPr marL="285750" indent="-285750" algn="l">
               <a:lnSpc>
-                <a:spcPct val="200000"/>
+                <a:spcPct val="110000"/>
               </a:lnSpc>
               <a:buFont typeface="Arial" panose="020B0604020202020204" pitchFamily="34" charset="0"/>
               <a:buChar char="•"/>
@@ -5700,9 +5705,9 @@
             </a:r>
           </a:p>
           <a:p>
-            <a:pPr marL="285750" indent="-285750" algn="just">
+            <a:pPr marL="285750" indent="-285750" algn="l">
               <a:lnSpc>
-                <a:spcPct val="200000"/>
+                <a:spcPct val="110000"/>
               </a:lnSpc>
               <a:buFont typeface="Arial" panose="020B0604020202020204" pitchFamily="34" charset="0"/>
               <a:buChar char="•"/>
@@ -5716,9 +5721,9 @@
             </a:r>
           </a:p>
           <a:p>
-            <a:pPr marL="285750" indent="-285750" algn="just">
+            <a:pPr marL="285750" indent="-285750" algn="l">
               <a:lnSpc>
-                <a:spcPct val="200000"/>
+                <a:spcPct val="110000"/>
               </a:lnSpc>
               <a:buFont typeface="Arial" panose="020B0604020202020204" pitchFamily="34" charset="0"/>
               <a:buChar char="•"/>
@@ -5732,9 +5737,9 @@
             </a:r>
           </a:p>
           <a:p>
-            <a:pPr marL="285750" indent="-285750" algn="just">
+            <a:pPr marL="285750" indent="-285750" algn="l">
               <a:lnSpc>
-                <a:spcPct val="200000"/>
+                <a:spcPct val="110000"/>
               </a:lnSpc>
               <a:buFont typeface="Arial" panose="020B0604020202020204" pitchFamily="34" charset="0"/>
               <a:buChar char="•"/>
@@ -5744,7 +5749,7 @@
                 <a:latin typeface="Arial" panose="020B0604020202020204" pitchFamily="34" charset="0"/>
                 <a:cs typeface="Arial" panose="020B0604020202020204" pitchFamily="34" charset="0"/>
               </a:rPr>
-              <a:t>Team Name (Registered on portal)</a:t>
+              <a:t>Team Name (Registered on portal)- Hawkeye</a:t>
             </a:r>
             <a:endParaRPr lang="en-IN" sz="2400" b="1" dirty="0">
               <a:latin typeface="Arial" panose="020B0604020202020204" pitchFamily="34" charset="0"/>
@@ -6091,7 +6096,7 @@
         <p:spPr>
           <a:xfrm>
             <a:off x="329773" y="252246"/>
-            <a:ext cx="1251857" cy="807334"/>
+            <a:ext cx="1828800" cy="807334"/>
           </a:xfrm>
           <a:prstGeom prst="ellipse">
             <a:avLst/>
@@ -6117,8 +6122,10 @@
           <a:p>
             <a:pPr algn="ctr"/>
             <a:r>
-              <a:rPr lang="en-US" dirty="0"/>
-              <a:t>Your Team Name</a:t>
+              <a:rPr lang="en-US" dirty="0" sz="1800" b="1">
+                <a:latin typeface="Arial"/>
+              </a:rPr>
+              <a:t>Hawkeye</a:t>
             </a:r>
             <a:endParaRPr lang="en-IN" dirty="0"/>
           </a:p>
@@ -6892,7 +6899,7 @@
         <p:spPr>
           <a:xfrm>
             <a:off x="329773" y="252246"/>
-            <a:ext cx="1251857" cy="807334"/>
+            <a:ext cx="1828800" cy="807334"/>
           </a:xfrm>
           <a:prstGeom prst="ellipse">
             <a:avLst/>
@@ -6918,8 +6925,10 @@
           <a:p>
             <a:pPr algn="ctr"/>
             <a:r>
-              <a:rPr lang="en-US" dirty="0"/>
-              <a:t>Your Team Name</a:t>
+              <a:rPr lang="en-US" dirty="0" sz="1800" b="1">
+                <a:latin typeface="Arial"/>
+              </a:rPr>
+              <a:t>Hawkeye</a:t>
             </a:r>
             <a:endParaRPr lang="en-IN" dirty="0"/>
           </a:p>
@@ -7700,7 +7709,7 @@
         <p:spPr>
           <a:xfrm>
             <a:off x="329773" y="252246"/>
-            <a:ext cx="1251857" cy="807334"/>
+            <a:ext cx="1828800" cy="807334"/>
           </a:xfrm>
           <a:prstGeom prst="ellipse">
             <a:avLst/>
@@ -7726,8 +7735,10 @@
           <a:p>
             <a:pPr algn="ctr"/>
             <a:r>
-              <a:rPr lang="en-US" dirty="0"/>
-              <a:t>Your Team Name</a:t>
+              <a:rPr lang="en-US" dirty="0" sz="1800" b="1">
+                <a:latin typeface="Arial"/>
+              </a:rPr>
+              <a:t>Hawkeye</a:t>
             </a:r>
             <a:endParaRPr lang="en-IN" dirty="0"/>
           </a:p>
@@ -8374,7 +8385,7 @@
         <p:spPr>
           <a:xfrm>
             <a:off x="329773" y="252246"/>
-            <a:ext cx="1251857" cy="807334"/>
+            <a:ext cx="1828800" cy="807334"/>
           </a:xfrm>
           <a:prstGeom prst="ellipse">
             <a:avLst/>
@@ -8400,8 +8411,10 @@
           <a:p>
             <a:pPr algn="ctr"/>
             <a:r>
-              <a:rPr lang="en-US" dirty="0"/>
-              <a:t>Your Team Name</a:t>
+              <a:rPr lang="en-US" dirty="0" sz="1800" b="1">
+                <a:latin typeface="Arial"/>
+              </a:rPr>
+              <a:t>Hawkeye</a:t>
             </a:r>
             <a:endParaRPr lang="en-IN" dirty="0"/>
           </a:p>
@@ -9110,7 +9123,7 @@
         <p:spPr>
           <a:xfrm>
             <a:off x="329773" y="252246"/>
-            <a:ext cx="1251857" cy="807334"/>
+            <a:ext cx="1828800" cy="807334"/>
           </a:xfrm>
           <a:prstGeom prst="ellipse">
             <a:avLst/>
@@ -9136,8 +9149,10 @@
           <a:p>
             <a:pPr algn="ctr"/>
             <a:r>
-              <a:rPr lang="en-US" dirty="0"/>
-              <a:t>Your Team Name</a:t>
+              <a:rPr lang="en-US" dirty="0" sz="1800" b="1">
+                <a:latin typeface="Arial"/>
+              </a:rPr>
+              <a:t>Hawkeye</a:t>
             </a:r>
             <a:endParaRPr lang="en-IN" dirty="0"/>
           </a:p>

</xml_diff>

<commit_message>
Drop the Team ID line from the SIH deck title page
Nothing to fill until the portal assigns one, and a dangling label
looks unfinished — the details block now ends at Team Name- Hawkeye.
Re-exported the portal PDF.
</commit_message>
<xml_diff>
--- a/deck/UnifyMat-SIH2026-Idea.pptx
+++ b/deck/UnifyMat-SIH2026-Idea.pptx
@@ -5733,22 +5733,6 @@
                 <a:latin typeface="Arial" panose="020B0604020202020204" pitchFamily="34" charset="0"/>
                 <a:cs typeface="Arial" panose="020B0604020202020204" pitchFamily="34" charset="0"/>
               </a:rPr>
-              <a:t>Team ID-</a:t>
-            </a:r>
-          </a:p>
-          <a:p>
-            <a:pPr marL="285750" indent="-285750" algn="l">
-              <a:lnSpc>
-                <a:spcPct val="110000"/>
-              </a:lnSpc>
-              <a:buFont typeface="Arial" panose="020B0604020202020204" pitchFamily="34" charset="0"/>
-              <a:buChar char="•"/>
-            </a:pPr>
-            <a:r>
-              <a:rPr lang="en-US" sz="2400" b="1" dirty="0">
-                <a:latin typeface="Arial" panose="020B0604020202020204" pitchFamily="34" charset="0"/>
-                <a:cs typeface="Arial" panose="020B0604020202020204" pitchFamily="34" charset="0"/>
-              </a:rPr>
               <a:t>Team Name (Registered on portal)- Hawkeye</a:t>
             </a:r>
             <a:endParaRPr lang="en-IN" sz="2400" b="1" dirty="0">

</xml_diff>